<commit_message>
Update dashboard and presentation
</commit_message>
<xml_diff>
--- a/Sentinel_Challenge_2_Presentation.pptx
+++ b/Sentinel_Challenge_2_Presentation.pptx
@@ -3088,7 +3088,7 @@
 </file>
 
 <file path=ppt/slides/slide1.xml><?xml version="1.0" encoding="utf-8"?>
-<p:sld xmlns:a="http://schemas.openxmlformats.org/drawingml/2006/main" xmlns:p="http://schemas.openxmlformats.org/presentationml/2006/main" xmlns:r="http://schemas.openxmlformats.org/officeDocument/2006/relationships">
+<p:sld xmlns:a="http://schemas.openxmlformats.org/drawingml/2006/main" xmlns:p="http://schemas.openxmlformats.org/presentationml/2006/main">
   <p:cSld>
     <p:bg>
       <p:bgPr>
@@ -3378,8 +3378,8 @@
                 </a:solidFill>
                 <a:latin typeface="Aptos"/>
               </a:rPr>
-              <a:t>A lightweight, streaming anomaly detector using a permitted
-sliding-window adaptive threshold.</a:t>
+              <a:t>A lightweight anomaly detector using a permitted
+unsupervised Isolation Forest.</a:t>
             </a:r>
           </a:p>
         </p:txBody>
@@ -4568,7 +4568,7 @@
                 </a:solidFill>
                 <a:latin typeface="Cascadia Code"/>
               </a:rPr>
-              <a:t>SIMULATED SIGNAL  ·  ONE FLAGGED POINT</a:t>
+              <a:t>ISOLATION FOREST CONCEPT  ·  ILLUSTRATION</a:t>
             </a:r>
           </a:p>
         </p:txBody>
@@ -4621,7 +4621,7 @@
 </file>
 
 <file path=ppt/slides/slide10.xml><?xml version="1.0" encoding="utf-8"?>
-<p:sld xmlns:a="http://schemas.openxmlformats.org/drawingml/2006/main" xmlns:p="http://schemas.openxmlformats.org/presentationml/2006/main" xmlns:r="http://schemas.openxmlformats.org/officeDocument/2006/relationships">
+<p:sld xmlns:a="http://schemas.openxmlformats.org/drawingml/2006/main" xmlns:p="http://schemas.openxmlformats.org/presentationml/2006/main">
   <p:cSld>
     <p:bg>
       <p:bgPr>
@@ -5230,7 +5230,7 @@
                 </a:solidFill>
                 <a:latin typeface="Aptos"/>
               </a:rPr>
-              <a:t>Load and inspect the organizer's NAB subset.</a:t>
+              <a:t>Public NAB example loads online; organizer subset still needed.</a:t>
             </a:r>
           </a:p>
         </p:txBody>
@@ -5316,7 +5316,7 @@
                 </a:solidFill>
                 <a:latin typeface="Aptos"/>
               </a:rPr>
-              <a:t>Evaluate event-F1, precision, recall, delay, runtime.</a:t>
+              <a:t>Load organizer CSV + labels JSON to score challenge data.</a:t>
             </a:r>
           </a:p>
         </p:txBody>
@@ -5402,7 +5402,7 @@
                 </a:solidFill>
                 <a:latin typeface="Aptos"/>
               </a:rPr>
-              <a:t>Connect a real timestamped stream; validate units and gaps.</a:t>
+              <a:t>Tune on validation data; preserve timestamp order.</a:t>
             </a:r>
           </a:p>
         </p:txBody>
@@ -5488,7 +5488,7 @@
                 </a:solidFill>
                 <a:latin typeface="Aptos"/>
               </a:rPr>
-              <a:t>Replace the demo password and deploy behind HTTPS.</a:t>
+              <a:t>Record challenge metrics only after the official evaluation.</a:t>
             </a:r>
           </a:p>
         </p:txBody>
@@ -5574,7 +5574,7 @@
                 </a:solidFill>
                 <a:latin typeface="Cascadia Code"/>
               </a:rPr>
-              <a:t>LIMIT: Python detector and JS demo are separate implementations.</a:t>
+              <a:t>LIMIT: Organizer challenge subset is not yet available.</a:t>
             </a:r>
           </a:p>
         </p:txBody>
@@ -7082,7 +7082,7 @@
 </file>
 
 <file path=ppt/slides/slide3.xml><?xml version="1.0" encoding="utf-8"?>
-<p:sld xmlns:a="http://schemas.openxmlformats.org/drawingml/2006/main" xmlns:p="http://schemas.openxmlformats.org/presentationml/2006/main" xmlns:r="http://schemas.openxmlformats.org/officeDocument/2006/relationships">
+<p:sld xmlns:a="http://schemas.openxmlformats.org/drawingml/2006/main" xmlns:p="http://schemas.openxmlformats.org/presentationml/2006/main">
   <p:cSld>
     <p:bg>
       <p:bgPr>
@@ -7246,7 +7246,7 @@
                 </a:solidFill>
                 <a:latin typeface="Aptos Display"/>
               </a:rPr>
-              <a:t>The benchmark is a labeled timeline—not random demo data</a:t>
+              <a:t>The website now uses real public NAB data—not generated values</a:t>
             </a:r>
           </a:p>
         </p:txBody>
@@ -7285,7 +7285,7 @@
                 </a:solidFill>
                 <a:latin typeface="Aptos"/>
               </a:rPr>
-              <a:t>The brief names a prepared Numenta Anomaly Benchmark (NAB) subset with hidden test windows.</a:t>
+              <a:t>The challenge subset has hidden test windows; this workspace contains a public NAB example.</a:t>
             </a:r>
           </a:p>
         </p:txBody>
@@ -7484,7 +7484,7 @@
                 </a:solidFill>
                 <a:latin typeface="Cascadia Code"/>
               </a:rPr>
-              <a:t>ILLUSTRATIVE ROW SHAPE</a:t>
+              <a:t>PUBLIC NAB: OFFICE TEMPERATURE</a:t>
             </a:r>
           </a:p>
         </p:txBody>
@@ -7601,7 +7601,7 @@
                 </a:solidFill>
                 <a:latin typeface="Cascadia Code"/>
               </a:rPr>
-              <a:t>LABEL*</a:t>
+              <a:t>LABEL</a:t>
             </a:r>
           </a:p>
         </p:txBody>
@@ -7675,7 +7675,7 @@
                 </a:solidFill>
                 <a:latin typeface="Cascadia Code"/>
               </a:rPr>
-              <a:t>10:00:01</a:t>
+              <a:t>Jul 04 00:00</a:t>
             </a:r>
           </a:p>
         </p:txBody>
@@ -7714,7 +7714,7 @@
                 </a:solidFill>
                 <a:latin typeface="Cascadia Code"/>
               </a:rPr>
-              <a:t>40.1</a:t>
+              <a:t>69.88</a:t>
             </a:r>
           </a:p>
         </p:txBody>
@@ -7753,7 +7753,7 @@
                 </a:solidFill>
                 <a:latin typeface="Cascadia Code"/>
               </a:rPr>
-              <a:t>normal</a:t>
+              <a:t>—</a:t>
             </a:r>
           </a:p>
         </p:txBody>
@@ -7827,7 +7827,7 @@
                 </a:solidFill>
                 <a:latin typeface="Cascadia Code"/>
               </a:rPr>
-              <a:t>10:00:02</a:t>
+              <a:t>Jul 04 01:00</a:t>
             </a:r>
           </a:p>
         </p:txBody>
@@ -7866,7 +7866,7 @@
                 </a:solidFill>
                 <a:latin typeface="Cascadia Code"/>
               </a:rPr>
-              <a:t>41.2</a:t>
+              <a:t>71.22</a:t>
             </a:r>
           </a:p>
         </p:txBody>
@@ -7905,7 +7905,7 @@
                 </a:solidFill>
                 <a:latin typeface="Cascadia Code"/>
               </a:rPr>
-              <a:t>normal</a:t>
+              <a:t>—</a:t>
             </a:r>
           </a:p>
         </p:txBody>
@@ -7979,7 +7979,7 @@
                 </a:solidFill>
                 <a:latin typeface="Cascadia Code"/>
               </a:rPr>
-              <a:t>10:00:03</a:t>
+              <a:t>Jul 04 02:00</a:t>
             </a:r>
           </a:p>
         </p:txBody>
@@ -8018,7 +8018,7 @@
                 </a:solidFill>
                 <a:latin typeface="Cascadia Code"/>
               </a:rPr>
-              <a:t>39.8</a:t>
+              <a:t>70.88</a:t>
             </a:r>
           </a:p>
         </p:txBody>
@@ -8057,7 +8057,7 @@
                 </a:solidFill>
                 <a:latin typeface="Cascadia Code"/>
               </a:rPr>
-              <a:t>normal</a:t>
+              <a:t>—</a:t>
             </a:r>
           </a:p>
         </p:txBody>
@@ -8131,7 +8131,7 @@
                 </a:solidFill>
                 <a:latin typeface="Cascadia Code"/>
               </a:rPr>
-              <a:t>10:00:04</a:t>
+              <a:t>Jul 04 03:00</a:t>
             </a:r>
           </a:p>
         </p:txBody>
@@ -8170,7 +8170,7 @@
                 </a:solidFill>
                 <a:latin typeface="Cascadia Code"/>
               </a:rPr>
-              <a:t>58.0</a:t>
+              <a:t>68.96</a:t>
             </a:r>
           </a:p>
         </p:txBody>
@@ -8209,7 +8209,7 @@
                 </a:solidFill>
                 <a:latin typeface="Cascadia Code"/>
               </a:rPr>
-              <a:t>event window</a:t>
+              <a:t>—</a:t>
             </a:r>
           </a:p>
         </p:txBody>
@@ -8283,7 +8283,7 @@
                 </a:solidFill>
                 <a:latin typeface="Cascadia Code"/>
               </a:rPr>
-              <a:t>10:00:05</a:t>
+              <a:t>Jul 04 04:00</a:t>
             </a:r>
           </a:p>
         </p:txBody>
@@ -8322,7 +8322,7 @@
                 </a:solidFill>
                 <a:latin typeface="Cascadia Code"/>
               </a:rPr>
-              <a:t>40.5</a:t>
+              <a:t>69.28</a:t>
             </a:r>
           </a:p>
         </p:txBody>
@@ -8361,7 +8361,7 @@
                 </a:solidFill>
                 <a:latin typeface="Cascadia Code"/>
               </a:rPr>
-              <a:t>normal</a:t>
+              <a:t>—</a:t>
             </a:r>
           </a:p>
         </p:txBody>
@@ -8400,7 +8400,7 @@
                 </a:solidFill>
                 <a:latin typeface="Aptos"/>
               </a:rPr>
-              <a:t>*Example only. Labels refer to organizer-supplied anomaly windows; no NAB file is in this workspace.</a:t>
+              <a:t>Public rows shown; NAB anomaly labels are separate time windows.</a:t>
             </a:r>
           </a:p>
         </p:txBody>
@@ -8603,7 +8603,7 @@
                 </a:solidFill>
                 <a:latin typeface="Aptos"/>
               </a:rPr>
-              <a:t>Read timestamp, value, event label.</a:t>
+              <a:t>Read timestamp + temperature.</a:t>
             </a:r>
           </a:p>
         </p:txBody>
@@ -8767,7 +8767,7 @@
                 </a:solidFill>
                 <a:latin typeface="Aptos"/>
               </a:rPr>
-              <a:t>Inspect gaps, duplicates, units, ordering.</a:t>
+              <a:t>Check ordering, gaps, and units.</a:t>
             </a:r>
           </a:p>
         </p:txBody>
@@ -8931,7 +8931,7 @@
                 </a:solidFill>
                 <a:latin typeface="Aptos"/>
               </a:rPr>
-              <a:t>Feed past and current values only.</a:t>
+              <a:t>Train Isolation Forest on clean patterns.</a:t>
             </a:r>
           </a:p>
         </p:txBody>
@@ -9181,7 +9181,7 @@
                 </a:solidFill>
                 <a:latin typeface="Cascadia Code"/>
               </a:rPr>
-              <a:t>NEXT REQUIRED INPUT: organizer's NAB subset + schema</a:t>
+              <a:t>PUBLIC NAB LOADED; CHALLENGE SUBSET STILL NEEDED</a:t>
             </a:r>
           </a:p>
         </p:txBody>
@@ -9195,7 +9195,7 @@
 </file>
 
 <file path=ppt/slides/slide4.xml><?xml version="1.0" encoding="utf-8"?>
-<p:sld xmlns:a="http://schemas.openxmlformats.org/drawingml/2006/main" xmlns:p="http://schemas.openxmlformats.org/presentationml/2006/main" xmlns:r="http://schemas.openxmlformats.org/officeDocument/2006/relationships">
+<p:sld xmlns:a="http://schemas.openxmlformats.org/drawingml/2006/main" xmlns:p="http://schemas.openxmlformats.org/presentationml/2006/main">
   <p:cSld>
     <p:bg>
       <p:bgPr>
@@ -9359,7 +9359,7 @@
                 </a:solidFill>
                 <a:latin typeface="Aptos Display"/>
               </a:rPr>
-              <a:t>From one reading to an explained event</a:t>
+              <a:t>From one NAB reading to an explained event</a:t>
             </a:r>
           </a:p>
         </p:txBody>
@@ -9398,7 +9398,7 @@
                 </a:solidFill>
                 <a:latin typeface="Aptos"/>
               </a:rPr>
-              <a:t>The Python detector is the reference algorithm; the browser runs a separate synthetic demo using matching settings.</a:t>
+              <a:t>The Python server trains the Isolation Forest, stores user readings, and sends predictions to the browser.</a:t>
             </a:r>
           </a:p>
         </p:txBody>
@@ -9683,7 +9683,7 @@
                 </a:solidFill>
                 <a:latin typeface="Cascadia Code"/>
               </a:rPr>
-              <a:t>INPUT</a:t>
+              <a:t>NAB + USER</a:t>
             </a:r>
           </a:p>
         </p:txBody>
@@ -9723,7 +9723,7 @@
                 <a:latin typeface="Aptos Display"/>
               </a:rPr>
               <a:t>timestamp
-+ numeric value</a:t>
++ value</a:t>
             </a:r>
           </a:p>
         </p:txBody>
@@ -9934,7 +9934,7 @@
                 </a:solidFill>
                 <a:latin typeface="Cascadia Code"/>
               </a:rPr>
-              <a:t>WINDOW</a:t>
+              <a:t>FEATURES</a:t>
             </a:r>
           </a:p>
         </p:txBody>
@@ -9973,8 +9973,8 @@
                 </a:solidFill>
                 <a:latin typeface="Aptos Display"/>
               </a:rPr>
-              <a:t>51 recent
-clean readings</a:t>
+              <a:t>value, change,
+local deviation</a:t>
             </a:r>
           </a:p>
         </p:txBody>
@@ -10185,7 +10185,7 @@
                 </a:solidFill>
                 <a:latin typeface="Cascadia Code"/>
               </a:rPr>
-              <a:t>SCORE</a:t>
+              <a:t>FOREST</a:t>
             </a:r>
           </a:p>
         </p:txBody>
@@ -10224,8 +10224,8 @@
                 </a:solidFill>
                 <a:latin typeface="Aptos Display"/>
               </a:rPr>
-              <a:t>median/MAD
-robust score</a:t>
+              <a:t>40 random
+isolation trees</a:t>
             </a:r>
           </a:p>
         </p:txBody>
@@ -10726,8 +10726,8 @@
                 </a:solidFill>
                 <a:latin typeface="Aptos Display"/>
               </a:rPr>
-              <a:t>limits, score,
-direction, reason</a:t>
+              <a:t>score, truth,
+review result</a:t>
             </a:r>
           </a:p>
         </p:txBody>
@@ -10813,7 +10813,7 @@
                 </a:solidFill>
                 <a:latin typeface="Cascadia Code"/>
               </a:rPr>
-              <a:t>PYTHON REFERENCE</a:t>
+              <a:t>TRAINING DATA</a:t>
             </a:r>
           </a:p>
         </p:txBody>
@@ -10852,7 +10852,7 @@
                 </a:solidFill>
                 <a:latin typeface="Cascadia Code"/>
               </a:rPr>
-              <a:t>sentinel.py  →  Sentinel.update(value)  →  result dictionary</a:t>
+              <a:t>Clean NAB + user readings confirmed normal</a:t>
             </a:r>
           </a:p>
         </p:txBody>
@@ -10938,7 +10938,7 @@
                 </a:solidFill>
                 <a:latin typeface="Cascadia Code"/>
               </a:rPr>
-              <a:t>BROWSER DEMO</a:t>
+              <a:t>PYTHON SERVER → WEB DASHBOARD</a:t>
             </a:r>
           </a:p>
         </p:txBody>
@@ -10977,7 +10977,7 @@
                 </a:solidFill>
                 <a:latin typeface="Cascadia Code"/>
               </a:rPr>
-              <a:t>app.js  →  generated signal  →  chart + event log</a:t>
+              <a:t>train + score  →  SQLite inputs  →  chart + evidence</a:t>
             </a:r>
           </a:p>
         </p:txBody>
@@ -11016,7 +11016,7 @@
                 </a:solidFill>
                 <a:latin typeface="Aptos"/>
               </a:rPr>
-              <a:t>The website does not ingest NAB or call the Python class yet.</a:t>
+              <a:t>The model excludes labeled windows and user-confirmed anomalies from training.</a:t>
             </a:r>
           </a:p>
         </p:txBody>
@@ -11030,7 +11030,7 @@
 </file>
 
 <file path=ppt/slides/slide5.xml><?xml version="1.0" encoding="utf-8"?>
-<p:sld xmlns:a="http://schemas.openxmlformats.org/drawingml/2006/main" xmlns:p="http://schemas.openxmlformats.org/presentationml/2006/main" xmlns:r="http://schemas.openxmlformats.org/officeDocument/2006/relationships">
+<p:sld xmlns:a="http://schemas.openxmlformats.org/drawingml/2006/main" xmlns:p="http://schemas.openxmlformats.org/presentationml/2006/main">
   <p:cSld>
     <p:bg>
       <p:bgPr>
@@ -11194,7 +11194,7 @@
                 </a:solidFill>
                 <a:latin typeface="Aptos Display"/>
               </a:rPr>
-              <a:t>A permitted sliding-window adaptive threshold</a:t>
+              <a:t>A permitted Isolation Forest</a:t>
             </a:r>
           </a:p>
         </p:txBody>
@@ -11233,7 +11233,7 @@
                 </a:solidFill>
                 <a:latin typeface="Aptos"/>
               </a:rPr>
-              <a:t>The brief explicitly permits sliding-window adaptive thresholds. Sentinel uses median + MAD for a robust, interpretable limit.</a:t>
+              <a:t>The brief permits Isolation Forests. Random splits isolate unusual points and assign each point an anomaly score.</a:t>
             </a:r>
           </a:p>
         </p:txBody>
@@ -11432,7 +11432,7 @@
                 </a:solidFill>
                 <a:latin typeface="Cascadia Code"/>
               </a:rPr>
-              <a:t>ROBUST SCORE</a:t>
+              <a:t>WHY ANOMALIES ISOLATE QUICKLY</a:t>
             </a:r>
           </a:p>
         </p:txBody>
@@ -11471,10 +11471,10 @@
                 </a:solidFill>
                 <a:latin typeface="Cascadia Code"/>
               </a:rPr>
-              <a:t>center = median(window)
-MAD = median(|x − center|)
-spread = max(1.4826 × MAD, ε)
-score = (new − center) / spread</a:t>
+              <a:t>Randomly choose a feature and split value.
+Repeat through many small trees.
+Typical points take more splits to isolate.
+Unusual points separate in fewer splits.</a:t>
             </a:r>
           </a:p>
         </p:txBody>
@@ -11513,7 +11513,7 @@
                 </a:solidFill>
                 <a:latin typeface="Cascadia Code"/>
               </a:rPr>
-              <a:t>Flag if |score| &gt; 3.5</a:t>
+              <a:t>Fewer splits → higher anomaly score</a:t>
             </a:r>
           </a:p>
         </p:txBody>
@@ -11591,7 +11591,7 @@
                 </a:solidFill>
                 <a:latin typeface="Aptos"/>
               </a:rPr>
-              <a:t>Window</a:t>
+              <a:t>Trees</a:t>
             </a:r>
           </a:p>
         </p:txBody>
@@ -11630,7 +11630,7 @@
                 </a:solidFill>
                 <a:latin typeface="Aptos"/>
               </a:rPr>
-              <a:t>51 accepted readings</a:t>
+              <a:t>40 randomized trees</a:t>
             </a:r>
           </a:p>
         </p:txBody>
@@ -11704,7 +11704,7 @@
                 </a:solidFill>
                 <a:latin typeface="Aptos"/>
               </a:rPr>
-              <a:t>Warm-up</a:t>
+              <a:t>Tree sample</a:t>
             </a:r>
           </a:p>
         </p:txBody>
@@ -11743,7 +11743,7 @@
                 </a:solidFill>
                 <a:latin typeface="Aptos"/>
               </a:rPr>
-              <a:t>12 readings</a:t>
+              <a:t>Up to 128 rows</a:t>
             </a:r>
           </a:p>
         </p:txBody>
@@ -11817,7 +11817,7 @@
                 </a:solidFill>
                 <a:latin typeface="Aptos"/>
               </a:rPr>
-              <a:t>Threshold</a:t>
+              <a:t>Features</a:t>
             </a:r>
           </a:p>
         </p:txBody>
@@ -11856,7 +11856,7 @@
                 </a:solidFill>
                 <a:latin typeface="Aptos"/>
               </a:rPr>
-              <a:t>3.5 robust-score units</a:t>
+              <a:t>Value, delta, local deviation</a:t>
             </a:r>
           </a:p>
         </p:txBody>
@@ -11930,7 +11930,7 @@
                 </a:solidFill>
                 <a:latin typeface="Aptos"/>
               </a:rPr>
-              <a:t>Update rule</a:t>
+              <a:t>Training</a:t>
             </a:r>
           </a:p>
         </p:txBody>
@@ -11969,7 +11969,7 @@
                 </a:solidFill>
                 <a:latin typeface="Aptos"/>
               </a:rPr>
-              <a:t>Do not learn from flagged points</a:t>
+              <a:t>Clean NAB + reviewed normal inputs</a:t>
             </a:r>
           </a:p>
         </p:txBody>
@@ -12090,7 +12090,7 @@
                 </a:solidFill>
                 <a:latin typeface="Cascadia Code"/>
               </a:rPr>
-              <a:t>WHY THIS FITS: low compute · adapts online · explains flags</a:t>
+              <a:t>LABELS OUT OF TRAINING: anomaly windows held aside</a:t>
             </a:r>
           </a:p>
         </p:txBody>
@@ -12129,7 +12129,7 @@
                 </a:solidFill>
                 <a:latin typeface="Aptos"/>
               </a:rPr>
-              <a:t>Fit-based choice, not an evidence-backed winner: NAB comparison is still pending.</a:t>
+              <a:t>Small dependency-free implementation; validate it against the organizer subset.</a:t>
             </a:r>
           </a:p>
         </p:txBody>
@@ -12143,7 +12143,7 @@
 </file>
 
 <file path=ppt/slides/slide6.xml><?xml version="1.0" encoding="utf-8"?>
-<p:sld xmlns:a="http://schemas.openxmlformats.org/drawingml/2006/main" xmlns:p="http://schemas.openxmlformats.org/presentationml/2006/main" xmlns:r="http://schemas.openxmlformats.org/officeDocument/2006/relationships">
+<p:sld xmlns:a="http://schemas.openxmlformats.org/drawingml/2006/main" xmlns:p="http://schemas.openxmlformats.org/presentationml/2006/main">
   <p:cSld>
     <p:bg>
       <p:bgPr>
@@ -12307,7 +12307,7 @@
                 </a:solidFill>
                 <a:latin typeface="Aptos Display"/>
               </a:rPr>
-              <a:t>Honest experiment log: no NAB runs have been completed</a:t>
+              <a:t>Public NAB replay runs in the website; hidden-subset evaluation is pending</a:t>
             </a:r>
           </a:p>
         </p:txBody>
@@ -12346,7 +12346,7 @@
                 </a:solidFill>
                 <a:latin typeface="Aptos"/>
               </a:rPr>
-              <a:t>The browser spike is an interaction demo, not a benchmark run. We will not present it as predictive performance.</a:t>
+              <a:t>The dashboard computes metrics on public NAB data. Organizer subset data is not present here.</a:t>
             </a:r>
           </a:p>
         </p:txBody>
@@ -12849,7 +12849,7 @@
                 </a:solidFill>
                 <a:latin typeface="Aptos"/>
               </a:rPr>
-              <a:t>Sentinel robust threshold</a:t>
+              <a:t>Sentinel Isolation Forest</a:t>
             </a:r>
           </a:p>
         </p:txBody>
@@ -12888,7 +12888,7 @@
                 </a:solidFill>
                 <a:latin typeface="Aptos"/>
               </a:rPr>
-              <a:t>median/MAD; 51, cutoff 3.5</a:t>
+              <a:t>40 trees; 128 sample; 2% cutoff</a:t>
             </a:r>
           </a:p>
         </p:txBody>
@@ -12927,7 +12927,7 @@
                 </a:solidFill>
                 <a:latin typeface="Aptos"/>
               </a:rPr>
-              <a:t>Current prototype</a:t>
+              <a:t>Dashboard</a:t>
             </a:r>
           </a:p>
         </p:txBody>
@@ -13001,7 +13001,7 @@
                 </a:solidFill>
                 <a:latin typeface="Aptos"/>
               </a:rPr>
-              <a:t>Threshold sweep</a:t>
+              <a:t>Tree/feature comparison</a:t>
             </a:r>
           </a:p>
         </p:txBody>
@@ -13040,7 +13040,7 @@
                 </a:solidFill>
                 <a:latin typeface="Aptos"/>
               </a:rPr>
-              <a:t>3.0 / 3.5 / 4.0 on validation</a:t>
+              <a:t>Feature sets and tree counts</a:t>
             </a:r>
           </a:p>
         </p:txBody>
@@ -13153,7 +13153,7 @@
                 </a:solidFill>
                 <a:latin typeface="Aptos"/>
               </a:rPr>
-              <a:t>Window sweep</a:t>
+              <a:t>Contamination sweep</a:t>
             </a:r>
           </a:p>
         </p:txBody>
@@ -13192,7 +13192,7 @@
                 </a:solidFill>
                 <a:latin typeface="Aptos"/>
               </a:rPr>
-              <a:t>25 / 51 / 101 clean points</a:t>
+              <a:t>1% / 2% / 3% on validation</a:t>
             </a:r>
           </a:p>
         </p:txBody>
@@ -13403,7 +13403,7 @@
                 </a:solidFill>
                 <a:latin typeface="Aptos"/>
               </a:rPr>
-              <a:t>Obtain the prepared NAB subset.</a:t>
+              <a:t>Load the organizer subset + window labels.</a:t>
             </a:r>
           </a:p>
         </p:txBody>
@@ -13575,7 +13575,7 @@
                 </a:solidFill>
                 <a:latin typeface="Aptos"/>
               </a:rPr>
-              <a:t>Log settings, runtime, and every result.</a:t>
+              <a:t>Record public and challenge scores separately.</a:t>
             </a:r>
           </a:p>
         </p:txBody>
@@ -13614,7 +13614,7 @@
                 </a:solidFill>
                 <a:latin typeface="Aptos"/>
               </a:rPr>
-              <a:t>Do not tune on hidden test windows.</a:t>
+              <a:t>Never tune on hidden test windows.</a:t>
             </a:r>
           </a:p>
         </p:txBody>
@@ -14817,7 +14817,7 @@
 </file>
 
 <file path=ppt/slides/slide8.xml><?xml version="1.0" encoding="utf-8"?>
-<p:sld xmlns:a="http://schemas.openxmlformats.org/drawingml/2006/main" xmlns:p="http://schemas.openxmlformats.org/presentationml/2006/main" xmlns:r="http://schemas.openxmlformats.org/officeDocument/2006/relationships">
+<p:sld xmlns:a="http://schemas.openxmlformats.org/drawingml/2006/main" xmlns:p="http://schemas.openxmlformats.org/presentationml/2006/main">
   <p:cSld>
     <p:bg>
       <p:bgPr>
@@ -14981,7 +14981,7 @@
                 </a:solidFill>
                 <a:latin typeface="Aptos Display"/>
               </a:rPr>
-              <a:t>Results are pending the official NAB data</a:t>
+              <a:t>The dashboard scores the public NAB example live</a:t>
             </a:r>
           </a:p>
         </p:txBody>
@@ -15020,7 +15020,7 @@
                 </a:solidFill>
                 <a:latin typeface="Aptos"/>
               </a:rPr>
-              <a:t>No hidden-test or NAB validation scores have been produced in this workspace. The table is intentionally not filled with demo numbers.</a:t>
+              <a:t>The site calculates event metrics on public NAB data. Organizer hidden-subset scores are not available yet.</a:t>
             </a:r>
           </a:p>
         </p:txBody>
@@ -15601,7 +15601,7 @@
                 </a:solidFill>
                 <a:latin typeface="Aptos"/>
               </a:rPr>
-              <a:t>Sentinel: median + MAD</a:t>
+              <a:t>Sentinel: Isolation Forest</a:t>
             </a:r>
           </a:p>
         </p:txBody>
@@ -15718,7 +15718,7 @@
                 </a:solidFill>
                 <a:latin typeface="Cascadia Code"/>
               </a:rPr>
-              <a:t>Prototype only</a:t>
+              <a:t>Public NAB</a:t>
             </a:r>
           </a:p>
         </p:txBody>
@@ -15792,7 +15792,7 @@
                 </a:solidFill>
                 <a:latin typeface="Aptos"/>
               </a:rPr>
-              <a:t>Isolation Forest / LOF*</a:t>
+              <a:t>Organizer hidden subset</a:t>
             </a:r>
           </a:p>
         </p:txBody>
@@ -15909,7 +15909,7 @@
                 </a:solidFill>
                 <a:latin typeface="Cascadia Code"/>
               </a:rPr>
-              <a:t>Optional baseline</a:t>
+              <a:t>Not loaded</a:t>
             </a:r>
           </a:p>
         </p:txBody>
@@ -15948,7 +15948,7 @@
                 </a:solidFill>
                 <a:latin typeface="Aptos"/>
               </a:rPr>
-              <a:t>*Run only if the chosen NAB subset and runtime budget make them appropriate.</a:t>
+              <a:t>Scores depend on the loaded dataset; public-example results are not hidden-test results.</a:t>
             </a:r>
           </a:p>
         </p:txBody>
@@ -16034,7 +16034,7 @@
                 </a:solidFill>
                 <a:latin typeface="Cascadia Code"/>
               </a:rPr>
-              <a:t>WHAT WE CAN SHOW TODAY</a:t>
+              <a:t>LIVE SITE METRICS</a:t>
             </a:r>
           </a:p>
         </p:txBody>
@@ -16073,7 +16073,7 @@
                 </a:solidFill>
                 <a:latin typeface="Aptos Display"/>
               </a:rPr>
-              <a:t>A synthetic reading is flagged and the UI explains why.</a:t>
+              <a:t>Precision, recall, event F1, delay, and runtime.</a:t>
             </a:r>
           </a:p>
         </p:txBody>
@@ -16112,7 +16112,7 @@
                 </a:solidFill>
                 <a:latin typeface="Aptos"/>
               </a:rPr>
-              <a:t>This demonstrates interaction and evidence formatting—not accuracy on real events.</a:t>
+              <a:t>Read measured values from the loaded dashboard. No numbers are invented in this deck.</a:t>
             </a:r>
           </a:p>
         </p:txBody>
@@ -16198,7 +16198,7 @@
                 </a:solidFill>
                 <a:latin typeface="Cascadia Code"/>
               </a:rPr>
-              <a:t>NO PERFORMANCE CLAIMS</a:t>
+              <a:t>PUBLIC EXAMPLE ONLY</a:t>
             </a:r>
           </a:p>
         </p:txBody>
@@ -16237,7 +16237,7 @@
                 </a:solidFill>
                 <a:latin typeface="Aptos"/>
               </a:rPr>
-              <a:t>Before submission: populate this slide from reproducible validation and organizer results.</a:t>
+              <a:t>Copy dashboard values here before presenting; label them as public NAB example results.</a:t>
             </a:r>
           </a:p>
         </p:txBody>
@@ -16251,7 +16251,7 @@
 </file>
 
 <file path=ppt/slides/slide9.xml><?xml version="1.0" encoding="utf-8"?>
-<p:sld xmlns:a="http://schemas.openxmlformats.org/drawingml/2006/main" xmlns:p="http://schemas.openxmlformats.org/presentationml/2006/main" xmlns:r="http://schemas.openxmlformats.org/officeDocument/2006/relationships">
+<p:sld xmlns:a="http://schemas.openxmlformats.org/drawingml/2006/main" xmlns:p="http://schemas.openxmlformats.org/presentationml/2006/main">
   <p:cSld>
     <p:bg>
       <p:bgPr>
@@ -16415,7 +16415,7 @@
                 </a:solidFill>
                 <a:latin typeface="Aptos Display"/>
               </a:rPr>
-              <a:t>A live demo with honest data labels and role-based access</a:t>
+              <a:t>Replay a public NAB series and inspect anomaly evidence</a:t>
             </a:r>
           </a:p>
         </p:txBody>
@@ -16454,7 +16454,7 @@
                 </a:solidFill>
                 <a:latin typeface="Aptos"/>
               </a:rPr>
-              <a:t>The website currently generates synthetic values. No company database, server packets, or live sensor stream is connected.</a:t>
+              <a:t>The public example is real office temperature, not the organizer subset or a live company feed.</a:t>
             </a:r>
           </a:p>
         </p:txBody>
@@ -16653,7 +16653,7 @@
                 </a:solidFill>
                 <a:latin typeface="Cascadia Code"/>
               </a:rPr>
-              <a:t>SENTINEL  /  SAMPLE EVENT</a:t>
+              <a:t>NAB  /  LABELED TEMPERATURE PERIOD</a:t>
             </a:r>
           </a:p>
         </p:txBody>
@@ -16692,7 +16692,7 @@
                 </a:solidFill>
                 <a:latin typeface="Aptos Display"/>
               </a:rPr>
-              <a:t>58.0</a:t>
+              <a:t>2 windows</a:t>
             </a:r>
           </a:p>
         </p:txBody>
@@ -16731,7 +16731,7 @@
                 </a:solidFill>
                 <a:latin typeface="Aptos"/>
               </a:rPr>
-              <a:t>observed value</a:t>
+              <a:t>published ground truth</a:t>
             </a:r>
           </a:p>
         </p:txBody>
@@ -16770,7 +16770,7 @@
                 </a:solidFill>
                 <a:latin typeface="Aptos"/>
               </a:rPr>
-              <a:t>Baseline 40.55   ·   Expected range 38.21–42.89</a:t>
+              <a:t>Dec 15–30, 2013 · Mar 29–Apr 20, 2014</a:t>
             </a:r>
           </a:p>
         </p:txBody>
@@ -16856,7 +16856,7 @@
                 </a:solidFill>
                 <a:latin typeface="Cascadia Code"/>
               </a:rPr>
-              <a:t>HIGH ANOMALY  ·  +15.1 ABOVE UPPER LIMIT</a:t>
+              <a:t>KNOWN PERIODS · NAB LABELS</a:t>
             </a:r>
           </a:p>
         </p:txBody>
@@ -16895,7 +16895,7 @@
                 </a:solidFill>
                 <a:latin typeface="Cascadia Code"/>
               </a:rPr>
-              <a:t>Robust score: +26.16</a:t>
+              <a:t>The table lists every flagged point and every missed point inside labeled windows.</a:t>
             </a:r>
           </a:p>
         </p:txBody>
@@ -16934,7 +16934,7 @@
                 </a:solidFill>
                 <a:latin typeface="Aptos"/>
               </a:rPr>
-              <a:t>Illustrative output from the built-in example; not a NAB result.</a:t>
+              <a:t>The labels are evaluation truth, not a claim that every point is detected.</a:t>
             </a:r>
           </a:p>
         </p:txBody>
@@ -17223,7 +17223,7 @@
                 </a:solidFill>
                 <a:latin typeface="Aptos"/>
               </a:rPr>
-              <a:t>Register @iiits.in → sign in → use demo controls after access opens</a:t>
+              <a:t>Register @iiits.in → sign in after access opens → explore dashboard</a:t>
             </a:r>
           </a:p>
         </p:txBody>
@@ -17301,7 +17301,7 @@
                 </a:solidFill>
                 <a:latin typeface="Aptos"/>
               </a:rPr>
-              <a:t>Demo controls: inject anomaly · simulate drift · pause · reset. Members see them only after the presenter opens access.</a:t>
+              <a:t>Confirm normal/anomaly; after saving and model refresh, the review popup closes automatically.</a:t>
             </a:r>
           </a:p>
         </p:txBody>

</xml_diff>

<commit_message>
Use shared Isolation Forest in standalone detector
</commit_message>
<xml_diff>
--- a/Sentinel_Challenge_2_Presentation.pptx
+++ b/Sentinel_Challenge_2_Presentation.pptx
@@ -5066,7 +5066,7 @@
 2  open http://127.0.0.1:8001
 Sign in with the presenter
 credentials in AUTH_SETUP.md
-Detector only: python3 sentinel.py</a:t>
+Standalone Isolation Forest: python3 sentinel.py</a:t>
             </a:r>
           </a:p>
         </p:txBody>
@@ -9398,7 +9398,7 @@
                 </a:solidFill>
                 <a:latin typeface="Aptos"/>
               </a:rPr>
-              <a:t>The Python server trains the Isolation Forest, stores user readings, and sends predictions to the browser.</a:t>
+              <a:t>The website server and sentinel.py both use the shared Isolation Forest to train and score readings.</a:t>
             </a:r>
           </a:p>
         </p:txBody>
@@ -12129,7 +12129,7 @@
                 </a:solidFill>
                 <a:latin typeface="Aptos"/>
               </a:rPr>
-              <a:t>Small dependency-free implementation; validate it against the organizer subset.</a:t>
+              <a:t>The website and standalone sentinel.py share this dependency-free Isolation Forest.</a:t>
             </a:r>
           </a:p>
         </p:txBody>

</xml_diff>